<commit_message>
Adapt PowerPoint speaker notes to slides (no HTML-only interactions)
Co-Authored-By: Claude Opus 5.5 <noreply@anthropic.com>
Claude-Session: https://claude.ai/code/session_01XKUL5T3Q1XbvqmYAzRSPJr
</commit_message>
<xml_diff>
--- a/lessons/Infant-Child-Feeding.pptx
+++ b/lessons/Infant-Child-Feeding.pptx
@@ -148,7 +148,7 @@
   <p:extLst>
     <p:ext uri="{521415D9-36F7-43E2-AB2F-B90AF26B5E84}">
       <p14:sectionLst xmlns:p14="http://schemas.microsoft.com/office/powerpoint/2010/main">
-        <p14:section name="Introduction" id="{2a51dde2-0c7a-6fcd-9a9e-4aac445d3e44}">
+        <p14:section name="Introduction" id="{107df6f9-e3b8-96f7-48b1-407149687705}">
           <p14:sldIdLst>
             <p14:sldId id="256"/>
             <p14:sldId id="257"/>
@@ -156,7 +156,7 @@
             <p14:sldId id="259"/>
           </p14:sldIdLst>
         </p14:section>
-        <p14:section name="Part 1 · Breastfeeding" id="{d63a6e9c-379a-b31a-e095-526150cca339}">
+        <p14:section name="Part 1 · Breastfeeding" id="{82b2e78f-69e1-d050-22d6-969c0036a565}">
           <p14:sldIdLst>
             <p14:sldId id="260"/>
             <p14:sldId id="261"/>
@@ -169,7 +169,7 @@
             <p14:sldId id="268"/>
           </p14:sldIdLst>
         </p14:section>
-        <p14:section name="Part 2 · Artificial Feeding" id="{272ee781-8cc0-22ae-4cf8-50bb9f9b8591}">
+        <p14:section name="Part 2 · Artificial Feeding" id="{28a173ed-73d1-6001-9edd-efa2c44e805c}">
           <p14:sldIdLst>
             <p14:sldId id="269"/>
             <p14:sldId id="270"/>
@@ -181,7 +181,7 @@
             <p14:sldId id="276"/>
           </p14:sldIdLst>
         </p14:section>
-        <p14:section name="Part 3 · NG Tube Feeding" id="{38b43157-12e5-db4b-5c49-9d6fced72e93}">
+        <p14:section name="Part 3 · NG Tube Feeding" id="{3052bbe5-056f-9be2-53a0-bbcde7797af7}">
           <p14:sldIdLst>
             <p14:sldId id="277"/>
             <p14:sldId id="278"/>
@@ -193,7 +193,7 @@
             <p14:sldId id="284"/>
           </p14:sldIdLst>
         </p14:section>
-        <p14:section name="Part 4 · Weaning" id="{b0fc87d3-7389-30ec-87db-3778b79bd97f}">
+        <p14:section name="Part 4 · Weaning" id="{96bae094-d8cb-c93c-2aef-72408353757b}">
           <p14:sldIdLst>
             <p14:sldId id="285"/>
             <p14:sldId id="286"/>
@@ -205,7 +205,7 @@
             <p14:sldId id="292"/>
           </p14:sldIdLst>
         </p14:section>
-        <p14:section name="Review" id="{cdb504bd-a552-8443-ffd5-72584d206a28}">
+        <p14:section name="Review" id="{b8cbb9c0-a562-1696-ba17-5e43b510312e}">
           <p14:sldIdLst>
             <p14:sldId id="293"/>
             <p14:sldId id="294"/>
@@ -619,8 +619,7 @@
             <a:r>
               <a:rPr lang="en-US" dirty="0"/>
               <a:t>Teacher notes:
-≈2 min. Introduce the four parts. Hover a part to highlight its 3D model, or click it to jump there.
-Tools: A Arabic · N notes · G overview · B build mode · L laser · D pen · R random student · T timer.
+≈2 min. Introduce the four parts of the lesson.
 شرح عربي:
 مرحبًا بكم في محاضرة تغذية الرضيع والطفل. تتكون من أربعة أجزاء:
 • الرضاعة الطبيعية
@@ -908,9 +907,7 @@
               <a:rPr lang="en-US" dirty="0"/>
               <a:t>Answers: Q1 B · Q2 C · Q3 C · Q4 B (shown on the next slide).
 Teacher notes:
-≈3 min. Give 10 seconds per question before clicking. Use R to pick who answers.
-شرح عربي:
-اختبار سريع للجزء الأول. امنح الطلاب ١٠ ثوانٍ لكل سؤال ثم اضغط الإجابة التي يختارونها. زر R يختار طالبًا عشوائيًا.</a:t>
+≈3 min. Give 10 seconds per question before clicking. Use R to pick who answers.</a:t>
             </a:r>
             <a:endParaRPr lang="en-US" dirty="0"/>
           </a:p>
@@ -999,9 +996,7 @@
             <a:r>
               <a:rPr lang="en-US" dirty="0"/>
               <a:t>Teacher notes:
-≈3 min. Give 10 seconds per question before clicking. Use R to pick who answers.
-شرح عربي:
-اختبار سريع للجزء الأول. امنح الطلاب ١٠ ثوانٍ لكل سؤال ثم اضغط الإجابة التي يختارونها. زر R يختار طالبًا عشوائيًا.</a:t>
+≈3 min. Give 10 seconds per question before clicking. Use R to pick who answers.</a:t>
             </a:r>
             <a:endParaRPr lang="en-US" dirty="0"/>
           </a:p>
@@ -1373,7 +1368,7 @@
             <a:r>
               <a:rPr lang="en-US" dirty="0"/>
               <a:t>Teacher notes:
-≈3 min. Press “Play the steps” to highlight each step in turn while students read it aloud.
+≈3 min. Ask students to read the steps aloud in order.
 شرح عربي:
 يعلّم الممرض مقدّم الرعاية:
 • غسل اليدين.
@@ -1475,14 +1470,13 @@
               <a:rPr lang="en-US" dirty="0"/>
               <a:t>The two pictures come from the interactive 3D model in the HTML version of this lesson.
 Teacher notes:
-≈3 min. In the 3D model, switch between “Correct tilt” and “Too flat” and ask what happens to the nipple. Drag to rotate the view.
+≈3 min. Compare the two 3D pictures: tilted bottle = nipple full of milk; too flat = air in the nipple.
 شرح عربي:
 طريقة الرضاعة بالزجاجة:
 • حمل الرضيع بوضع شبه قائم، مع دعم الرأس والرقبة.
 • إمالة الزجاجة بحيث تبقى الحلمة مليئة بالحليب.
 • السماح للطفل بالتوقف أثناء الرضعة، والتجشؤ عند الحاجة.
-ممنوع: إجبار الطفل على إنهاء الزجاجة، إسناد الزجاجة وترك الطفل وحده، أو إرضاعه وهو مستلقٍ تمامًا.
-في المجسم ثلاثي الأبعاد: اضغط «Correct tilt» ثم «Too flat» ولاحظ الحلمة.</a:t>
+ممنوع: إجبار الطفل على إنهاء الزجاجة، إسناد الزجاجة وترك الطفل وحده، أو إرضاعه وهو مستلقٍ تمامًا.</a:t>
             </a:r>
             <a:endParaRPr lang="en-US" dirty="0"/>
           </a:p>
@@ -2040,7 +2034,7 @@
               <a:rPr lang="en-US" dirty="0"/>
               <a:t>The picture comes from the interactive 3D model in the HTML version (with the tube insertion animation).
 Teacher notes:
-≈3 min. Press “Insert tube” and trace the path: nose → oesophagus → stomach. Rotate the model to show that the airway sits right in front of the oesophagus.
+≈3 min. Trace the path on the 3D picture: nose → oesophagus → stomach. Point out that the airway sits right in front of the oesophagus.
 شرح عربي:
 التغذية بالأنبوب الأنفي المعدي: إعطاء الغذاء أو السوائل أو الدواء عبر أنبوب يُدخل من الأنف إلى المعدة.
 قد تُستخدم عندما الرضيع أو الطفل:
@@ -2049,8 +2043,7 @@
 • لديه ضعف في البلع.
 • لديه حالات عصبية أو طبية معينة.
 • يحتاج تغذية معوية مؤقتة.
-تتطلب كادرًا صحيًا مدرّبًا والتحقق المناسب من موضع الأنبوب.
-في المجسم: اضغط «Insert tube» لمشاهدة مسار الأنبوب من الأنف إلى المعدة، واسحب لتدوير المجسم.</a:t>
+تتطلب كادرًا صحيًا مدرّبًا والتحقق المناسب من موضع الأنبوب.</a:t>
             </a:r>
             <a:endParaRPr lang="en-US" dirty="0"/>
           </a:p>
@@ -2237,7 +2230,7 @@
               <a:rPr lang="en-US" dirty="0"/>
               <a:t>Ask a student to read each check aloud and tick it on the board.
 Teacher notes:
-≈3 min. A student ticks each check aloud; the feed unlocks only after all seven. Then press “Placement uncertain?”.
+≈3 min. Ask a student to read each check aloud.
 شرح عربي:
 قبل التغذية بالأنبوب، يجب على الممرض:
 • التحقق من وصفة التغذية.
@@ -4327,7 +4320,7 @@
             <a:r>
               <a:rPr lang="en-US" dirty="0"/>
               <a:t>Teacher notes:
-≈3 min. Use Build mode (B): ask students to guess each benefit before it appears.
+≈3 min. Ask students to guess each benefit before you reveal it.
 شرح عربي:
 فوائد للرضيع: تغذية مثالية، سهل الهضم، يحتوي على أجسام مضادة وعوامل مناعية، يقلل التهابات الجهاز التنفسي والهضمي، يدعم النمو والتطور الطبيعي، ويقلل خطر زيادة الوزن والسمنة في الطفولة.
 فوائد للأم: يساعد على انقباض الرحم بعد الولادة، قد يقلل نزيف ما بعد الولادة، يعزز الترابط بين الأم والطفل، ومريح واقتصادي.</a:t>
@@ -4516,7 +4509,7 @@
             <a:r>
               <a:rPr lang="en-US" dirty="0"/>
               <a:t>Teacher notes:
-≈4 min. Let the latch animation loop while you explain steps 5 and 6. Use the two figures to show “head and body in a straight line”.
+≈4 min. Use the latch picture for steps 5 and 6, and the two figures for “head and body in a straight line”.
 شرح عربي:
 يعلّم الممرض الأم:
 • غسل اليدين.

</xml_diff>

<commit_message>
Fix formula-types speaker note for PowerPoint
Co-Authored-By: Claude Opus 5.5 <noreply@anthropic.com>
Claude-Session: https://claude.ai/code/session_01XKUL5T3Q1XbvqmYAzRSPJr
</commit_message>
<xml_diff>
--- a/lessons/Infant-Child-Feeding.pptx
+++ b/lessons/Infant-Child-Feeding.pptx
@@ -148,7 +148,7 @@
   <p:extLst>
     <p:ext uri="{521415D9-36F7-43E2-AB2F-B90AF26B5E84}">
       <p14:sectionLst xmlns:p14="http://schemas.microsoft.com/office/powerpoint/2010/main">
-        <p14:section name="Introduction" id="{107df6f9-e3b8-96f7-48b1-407149687705}">
+        <p14:section name="Introduction" id="{19e47426-ea41-bea9-4ac9-7841bb506e0c}">
           <p14:sldIdLst>
             <p14:sldId id="256"/>
             <p14:sldId id="257"/>
@@ -156,7 +156,7 @@
             <p14:sldId id="259"/>
           </p14:sldIdLst>
         </p14:section>
-        <p14:section name="Part 1 · Breastfeeding" id="{82b2e78f-69e1-d050-22d6-969c0036a565}">
+        <p14:section name="Part 1 · Breastfeeding" id="{718a34d5-5ed1-ec6d-99be-956e30e1b729}">
           <p14:sldIdLst>
             <p14:sldId id="260"/>
             <p14:sldId id="261"/>
@@ -169,7 +169,7 @@
             <p14:sldId id="268"/>
           </p14:sldIdLst>
         </p14:section>
-        <p14:section name="Part 2 · Artificial Feeding" id="{28a173ed-73d1-6001-9edd-efa2c44e805c}">
+        <p14:section name="Part 2 · Artificial Feeding" id="{261068da-92fd-b1c2-c9f5-8c5f104604b9}">
           <p14:sldIdLst>
             <p14:sldId id="269"/>
             <p14:sldId id="270"/>
@@ -181,7 +181,7 @@
             <p14:sldId id="276"/>
           </p14:sldIdLst>
         </p14:section>
-        <p14:section name="Part 3 · NG Tube Feeding" id="{3052bbe5-056f-9be2-53a0-bbcde7797af7}">
+        <p14:section name="Part 3 · NG Tube Feeding" id="{1723957f-a785-1f1c-9058-a5d4e8d06698}">
           <p14:sldIdLst>
             <p14:sldId id="277"/>
             <p14:sldId id="278"/>
@@ -193,7 +193,7 @@
             <p14:sldId id="284"/>
           </p14:sldIdLst>
         </p14:section>
-        <p14:section name="Part 4 · Weaning" id="{96bae094-d8cb-c93c-2aef-72408353757b}">
+        <p14:section name="Part 4 · Weaning" id="{c9ecaa8d-c21b-e935-c713-a174f20b78a4}">
           <p14:sldIdLst>
             <p14:sldId id="285"/>
             <p14:sldId id="286"/>
@@ -205,7 +205,7 @@
             <p14:sldId id="292"/>
           </p14:sldIdLst>
         </p14:section>
-        <p14:section name="Review" id="{b8cbb9c0-a562-1696-ba17-5e43b510312e}">
+        <p14:section name="Review" id="{fcbeec76-0ad1-f819-ddd1-b1d9a22fd8ec}">
           <p14:sldIdLst>
             <p14:sldId id="293"/>
             <p14:sldId id="294"/>
@@ -1273,7 +1273,7 @@
             <a:r>
               <a:rPr lang="en-US" dirty="0"/>
               <a:t>Teacher notes:
-≈2 min. Hover a tin to lift it as you introduce each type.
+≈2 min. Introduce each type of formula in turn.
 شرح عربي:
 أنواع الحليب الصناعي الشائعة:
 • الحليب العادي المعتمد على حليب البقر: مناسب لمعظم الرضّع الأصحاء مكتملي النمو.

</xml_diff>

<commit_message>
Infant feeding PowerPoint: add presenter name and NG tube insertion steps
Co-Authored-By: Claude Opus 5.5 <noreply@anthropic.com>
Claude-Session: https://claude.ai/code/session_01XKUL5T3Q1XbvqmYAzRSPJr
</commit_message>
<xml_diff>
--- a/lessons/Infant-Child-Feeding.pptx
+++ b/lessons/Infant-Child-Feeding.pptx
@@ -148,7 +148,7 @@
   <p:extLst>
     <p:ext uri="{521415D9-36F7-43E2-AB2F-B90AF26B5E84}">
       <p14:sectionLst xmlns:p14="http://schemas.microsoft.com/office/powerpoint/2010/main">
-        <p14:section name="Introduction" id="{19e47426-ea41-bea9-4ac9-7841bb506e0c}">
+        <p14:section name="Introduction" id="{7adb6880-600e-ab08-d337-6c6a91bcdcc1}">
           <p14:sldIdLst>
             <p14:sldId id="256"/>
             <p14:sldId id="257"/>
@@ -156,7 +156,7 @@
             <p14:sldId id="259"/>
           </p14:sldIdLst>
         </p14:section>
-        <p14:section name="Part 1 · Breastfeeding" id="{718a34d5-5ed1-ec6d-99be-956e30e1b729}">
+        <p14:section name="Part 1 · Breastfeeding" id="{d318cbe4-266b-f54e-4a1a-5393a1be07c9}">
           <p14:sldIdLst>
             <p14:sldId id="260"/>
             <p14:sldId id="261"/>
@@ -169,7 +169,7 @@
             <p14:sldId id="268"/>
           </p14:sldIdLst>
         </p14:section>
-        <p14:section name="Part 2 · Artificial Feeding" id="{261068da-92fd-b1c2-c9f5-8c5f104604b9}">
+        <p14:section name="Part 2 · Artificial Feeding" id="{5b7bc620-4429-ea59-a4b7-9951148535aa}">
           <p14:sldIdLst>
             <p14:sldId id="269"/>
             <p14:sldId id="270"/>
@@ -181,7 +181,7 @@
             <p14:sldId id="276"/>
           </p14:sldIdLst>
         </p14:section>
-        <p14:section name="Part 3 · NG Tube Feeding" id="{1723957f-a785-1f1c-9058-a5d4e8d06698}">
+        <p14:section name="Part 3 · NG Tube Feeding" id="{c927c95b-7e35-51a1-fe82-9943b697d1c6}">
           <p14:sldIdLst>
             <p14:sldId id="277"/>
             <p14:sldId id="278"/>
@@ -193,7 +193,7 @@
             <p14:sldId id="284"/>
           </p14:sldIdLst>
         </p14:section>
-        <p14:section name="Part 4 · Weaning" id="{c9ecaa8d-c21b-e935-c713-a174f20b78a4}">
+        <p14:section name="Part 4 · Weaning" id="{be9a0a2e-f716-bca5-18b1-c59ac15a379c}">
           <p14:sldIdLst>
             <p14:sldId id="285"/>
             <p14:sldId id="286"/>
@@ -205,7 +205,7 @@
             <p14:sldId id="292"/>
           </p14:sldIdLst>
         </p14:section>
-        <p14:section name="Review" id="{fcbeec76-0ad1-f819-ddd1-b1d9a22fd8ec}">
+        <p14:section name="Review" id="{e268f0fd-6587-98aa-c209-fdaefe19d8af}">
           <p14:sldIdLst>
             <p14:sldId id="293"/>
             <p14:sldId id="294"/>
@@ -2329,20 +2329,19 @@
             <a:r>
               <a:rPr lang="en-US" dirty="0"/>
               <a:t>Teacher notes:
-≈3 min. Walk the timeline; at step 7, point to the STOP box and its four signs.
+≈4 min. Walk the steps in order. At step 3, demonstrate the measurement (nose → earlobe → midpoint between xiphoid and umbilicus) on a doll or manikin. At step 8, point to the STOP box.
 شرح عربي:
-خطوات التغذية بالأنبوب:
-• نظافة اليدين.
-• وضع الرضيع بأمان، غالبًا بوضع شبه قائم.
-• التحقق من موضع الأنبوب حسب البروتوكول.
-• التحقق من الرضعة الموصوفة.
-• إعطاء الرضعة بالسرعة الموصوفة.
-• مراقبة الرضيع طوال الرضعة.
-• إيقاف التغذية عند ظهور علامات مقلقة.
-• غسل الأنبوب فقط حسب البروتوكول الموصوف أو المناسب.
-• إبقاء الرضيع في وضعية مناسبة بعد التغذية.
-• توثيق الرضعة واستجابة الرضيع.
-أوقف التغذية عند ضيق التنفس الشديد أو القيء أو السعال أو الزرقة أو أي علامة مقلقة أخرى.</a:t>
+خطوات إدخال الأنبوب الأنفي المعدي:
+• غسل اليدين وتجهيز الأنبوب، المادة المزلّقة، الحقنة، ورق قياس الحموضة (pH)، وشريط التثبيت.
+• شرح الإجراء للطفل أو الأهل، ووضع الطفل في وضعية قائمة أو شبه قائمة.
+• قياس طول الأنبوب من الأنف ← شحمة الأذن ← منتصف المسافة بين الناتئ الخنجري والسرة.
+• وضع علامة على الطول المقاس على الأنبوب.
+• تزليق طرف الأنبوب بمادة مزلّقة ذائبة في الماء.
+• إدخال الأنبوب بلطف عبر فتحة الأنف مع توجيهه للخلف وليس للأعلى.
+• تشجيع البلع عند الأطفال الأكبر سنًا، واستخدام اللهّاية لمساعدة الرضّع على البلع.
+• عند حدوث سعال شديد أو اختناق أو زرقة أو ضيق تنفس: أوقف الإجراء وأخرج الأنبوب.
+• التأكد من موضع الأنبوب بسحب محتوى المعدة وفحص الحموضة (pH) حسب البروتوكول المحلي، وقد نحتاج إلى أشعة إذا كان الموضع غير مؤكد.
+• تثبيت الأنبوب على الأنف أو الخد، وتسجيل الطول الخارجي للأنبوب، وعدم إعطاء أي تغذية أو دواء حتى يتم التأكد من الموضع الصحيح.</a:t>
             </a:r>
             <a:endParaRPr lang="en-US" dirty="0"/>
           </a:p>
@@ -4664,7 +4663,7 @@
         <p:spPr>
           <a:xfrm>
             <a:off x="548640" y="6446520"/>
-            <a:ext cx="5486400" cy="274320"/>
+            <a:ext cx="7315200" cy="274320"/>
           </a:xfrm>
           <a:prstGeom prst="rect">
             <a:avLst/>
@@ -4685,7 +4684,7 @@
                   <a:srgbClr val="4B636B"/>
                 </a:solidFill>
               </a:rPr>
-              <a:t>Infant and Child Feeding</a:t>
+              <a:t>Infant and Child Feeding · Dr. Ruqaiah Aidaros Alhebshi</a:t>
             </a:r>
             <a:endParaRPr lang="en-US" sz="1000" dirty="0"/>
           </a:p>
@@ -5233,8 +5232,8 @@
         </p:nvSpPr>
         <p:spPr>
           <a:xfrm>
-            <a:off x="548640" y="914400"/>
-            <a:ext cx="6035040" cy="2103120"/>
+            <a:off x="548640" y="685800"/>
+            <a:ext cx="6035040" cy="1920240"/>
           </a:xfrm>
           <a:prstGeom prst="rect">
             <a:avLst/>
@@ -5250,7 +5249,7 @@
               <a:buNone/>
             </a:pPr>
             <a:r>
-              <a:rPr lang="en-US" sz="6000" b="1" dirty="0">
+              <a:rPr lang="en-US" sz="5600" b="1" dirty="0">
                 <a:solidFill>
                   <a:schemeClr val="tx1"/>
                 </a:solidFill>
@@ -5262,31 +5261,31 @@
               <a:buNone/>
             </a:pPr>
             <a:r>
-              <a:rPr lang="en-US" sz="6000" b="1" dirty="0">
+              <a:rPr lang="en-US" sz="5600" b="1" dirty="0">
                 <a:solidFill>
                   <a:schemeClr val="accent5"/>
                 </a:solidFill>
               </a:rPr>
               <a:t>Feeding</a:t>
             </a:r>
-            <a:endParaRPr lang="en-US" sz="6000" dirty="0"/>
-          </a:p>
-        </p:txBody>
-      </p:sp>
-      <p:sp>
-        <p:nvSpPr>
-          <p:cNvPr id="4" name="Part card"/>
-          <p:cNvSpPr/>
-          <p:nvPr/>
-        </p:nvSpPr>
-        <p:spPr>
-          <a:xfrm>
-            <a:off x="548640" y="3429000"/>
-            <a:ext cx="2788920" cy="713232"/>
+            <a:endParaRPr lang="en-US" sz="5600" dirty="0"/>
+          </a:p>
+        </p:txBody>
+      </p:sp>
+      <p:sp>
+        <p:nvSpPr>
+          <p:cNvPr id="4" name="Author card"/>
+          <p:cNvSpPr/>
+          <p:nvPr/>
+        </p:nvSpPr>
+        <p:spPr>
+          <a:xfrm>
+            <a:off x="548640" y="2743200"/>
+            <a:ext cx="5760720" cy="1051560"/>
           </a:xfrm>
           <a:prstGeom prst="roundRect">
             <a:avLst>
-              <a:gd name="adj" fmla="val 15385"/>
+              <a:gd name="adj" fmla="val 10435"/>
             </a:avLst>
           </a:prstGeom>
           <a:solidFill>
@@ -5315,17 +5314,53 @@
         </p:nvSpPr>
         <p:spPr>
           <a:xfrm>
-            <a:off x="731520" y="3429000"/>
-            <a:ext cx="640080" cy="713232"/>
-          </a:xfrm>
-          <a:prstGeom prst="rect">
-            <a:avLst/>
-          </a:prstGeom>
-          <a:noFill/>
-          <a:ln/>
-        </p:spPr>
-        <p:txBody>
-          <a:bodyPr wrap="square" lIns="0" tIns="0" rIns="0" bIns="0" rtlCol="0" anchor="ctr"/>
+            <a:off x="822960" y="2871216"/>
+            <a:ext cx="5303520" cy="274320"/>
+          </a:xfrm>
+          <a:prstGeom prst="rect">
+            <a:avLst/>
+          </a:prstGeom>
+          <a:noFill/>
+          <a:ln/>
+        </p:spPr>
+        <p:txBody>
+          <a:bodyPr wrap="square" lIns="0" tIns="0" rIns="0" bIns="0" rtlCol="0" anchor="t"/>
+          <a:lstStyle/>
+          <a:p>
+            <a:pPr indent="0" marL="0">
+              <a:buNone/>
+            </a:pPr>
+            <a:r>
+              <a:rPr lang="en-US" sz="1200" b="1" spc="200" kern="0" dirty="0">
+                <a:solidFill>
+                  <a:srgbClr val="4B636B"/>
+                </a:solidFill>
+              </a:rPr>
+              <a:t>PRESENTED BY</a:t>
+            </a:r>
+            <a:endParaRPr lang="en-US" sz="1200" dirty="0"/>
+          </a:p>
+        </p:txBody>
+      </p:sp>
+      <p:sp>
+        <p:nvSpPr>
+          <p:cNvPr id="6" name="Text 4"/>
+          <p:cNvSpPr txBox="1"/>
+          <p:nvPr/>
+        </p:nvSpPr>
+        <p:spPr>
+          <a:xfrm>
+            <a:off x="822960" y="3154680"/>
+            <a:ext cx="5394960" cy="502920"/>
+          </a:xfrm>
+          <a:prstGeom prst="rect">
+            <a:avLst/>
+          </a:prstGeom>
+          <a:noFill/>
+          <a:ln/>
+        </p:spPr>
+        <p:txBody>
+          <a:bodyPr wrap="square" lIns="0" tIns="0" rIns="0" bIns="0" rtlCol="0" anchor="t"/>
           <a:lstStyle/>
           <a:p>
             <a:pPr indent="0" marL="0">
@@ -5334,10 +5369,10 @@
             <a:r>
               <a:rPr lang="en-US" sz="2600" b="1" dirty="0">
                 <a:solidFill>
-                  <a:schemeClr val="accent1"/>
-                </a:solidFill>
-              </a:rPr>
-              <a:t>01</a:t>
+                  <a:schemeClr val="accent5"/>
+                </a:solidFill>
+              </a:rPr>
+              <a:t>Dr. Ruqaiah Aidaros Alhebshi</a:t>
             </a:r>
             <a:endParaRPr lang="en-US" sz="2600" dirty="0"/>
           </a:p>
@@ -5345,49 +5380,13 @@
       </p:sp>
       <p:sp>
         <p:nvSpPr>
-          <p:cNvPr id="6" name="Text 4"/>
-          <p:cNvSpPr txBox="1"/>
-          <p:nvPr/>
-        </p:nvSpPr>
-        <p:spPr>
-          <a:xfrm>
-            <a:off x="1371600" y="3429000"/>
-            <a:ext cx="1920240" cy="713232"/>
-          </a:xfrm>
-          <a:prstGeom prst="rect">
-            <a:avLst/>
-          </a:prstGeom>
-          <a:noFill/>
-          <a:ln/>
-        </p:spPr>
-        <p:txBody>
-          <a:bodyPr wrap="square" lIns="0" tIns="0" rIns="0" bIns="0" rtlCol="0" anchor="ctr"/>
-          <a:lstStyle/>
-          <a:p>
-            <a:pPr indent="0" marL="0">
-              <a:buNone/>
-            </a:pPr>
-            <a:r>
-              <a:rPr lang="en-US" sz="1700" b="1" dirty="0">
-                <a:solidFill>
-                  <a:schemeClr val="tx1"/>
-                </a:solidFill>
-              </a:rPr>
-              <a:t>Breastfeeding</a:t>
-            </a:r>
-            <a:endParaRPr lang="en-US" sz="1700" dirty="0"/>
-          </a:p>
-        </p:txBody>
-      </p:sp>
-      <p:sp>
-        <p:nvSpPr>
           <p:cNvPr id="7" name="Part card"/>
           <p:cNvSpPr/>
           <p:nvPr/>
         </p:nvSpPr>
         <p:spPr>
           <a:xfrm>
-            <a:off x="3520440" y="3429000"/>
+            <a:off x="548640" y="4114800"/>
             <a:ext cx="2788920" cy="713232"/>
           </a:xfrm>
           <a:prstGeom prst="roundRect">
@@ -5421,7 +5420,7 @@
         </p:nvSpPr>
         <p:spPr>
           <a:xfrm>
-            <a:off x="3703320" y="3429000"/>
+            <a:off x="731520" y="4114800"/>
             <a:ext cx="640080" cy="713232"/>
           </a:xfrm>
           <a:prstGeom prst="rect">
@@ -5440,10 +5439,10 @@
             <a:r>
               <a:rPr lang="en-US" sz="2600" b="1" dirty="0">
                 <a:solidFill>
-                  <a:schemeClr val="accent2"/>
-                </a:solidFill>
-              </a:rPr>
-              <a:t>02</a:t>
+                  <a:schemeClr val="accent1"/>
+                </a:solidFill>
+              </a:rPr>
+              <a:t>01</a:t>
             </a:r>
             <a:endParaRPr lang="en-US" sz="2600" dirty="0"/>
           </a:p>
@@ -5457,7 +5456,7 @@
         </p:nvSpPr>
         <p:spPr>
           <a:xfrm>
-            <a:off x="4343400" y="3429000"/>
+            <a:off x="1371600" y="4114800"/>
             <a:ext cx="1920240" cy="713232"/>
           </a:xfrm>
           <a:prstGeom prst="rect">
@@ -5479,7 +5478,7 @@
                   <a:schemeClr val="tx1"/>
                 </a:solidFill>
               </a:rPr>
-              <a:t>Artificial Feeding</a:t>
+              <a:t>Breastfeeding</a:t>
             </a:r>
             <a:endParaRPr lang="en-US" sz="1700" dirty="0"/>
           </a:p>
@@ -5493,7 +5492,7 @@
         </p:nvSpPr>
         <p:spPr>
           <a:xfrm>
-            <a:off x="548640" y="4297680"/>
+            <a:off x="3520440" y="4114800"/>
             <a:ext cx="2788920" cy="713232"/>
           </a:xfrm>
           <a:prstGeom prst="roundRect">
@@ -5527,7 +5526,7 @@
         </p:nvSpPr>
         <p:spPr>
           <a:xfrm>
-            <a:off x="731520" y="4297680"/>
+            <a:off x="3703320" y="4114800"/>
             <a:ext cx="640080" cy="713232"/>
           </a:xfrm>
           <a:prstGeom prst="rect">
@@ -5546,10 +5545,10 @@
             <a:r>
               <a:rPr lang="en-US" sz="2600" b="1" dirty="0">
                 <a:solidFill>
-                  <a:schemeClr val="accent3"/>
-                </a:solidFill>
-              </a:rPr>
-              <a:t>03</a:t>
+                  <a:schemeClr val="accent2"/>
+                </a:solidFill>
+              </a:rPr>
+              <a:t>02</a:t>
             </a:r>
             <a:endParaRPr lang="en-US" sz="2600" dirty="0"/>
           </a:p>
@@ -5563,7 +5562,7 @@
         </p:nvSpPr>
         <p:spPr>
           <a:xfrm>
-            <a:off x="1371600" y="4297680"/>
+            <a:off x="4343400" y="4114800"/>
             <a:ext cx="1920240" cy="713232"/>
           </a:xfrm>
           <a:prstGeom prst="rect">
@@ -5585,7 +5584,7 @@
                   <a:schemeClr val="tx1"/>
                 </a:solidFill>
               </a:rPr>
-              <a:t>NG Tube Feeding</a:t>
+              <a:t>Artificial Feeding</a:t>
             </a:r>
             <a:endParaRPr lang="en-US" sz="1700" dirty="0"/>
           </a:p>
@@ -5599,7 +5598,7 @@
         </p:nvSpPr>
         <p:spPr>
           <a:xfrm>
-            <a:off x="3520440" y="4297680"/>
+            <a:off x="548640" y="4983480"/>
             <a:ext cx="2788920" cy="713232"/>
           </a:xfrm>
           <a:prstGeom prst="roundRect">
@@ -5633,7 +5632,7 @@
         </p:nvSpPr>
         <p:spPr>
           <a:xfrm>
-            <a:off x="3703320" y="4297680"/>
+            <a:off x="731520" y="4983480"/>
             <a:ext cx="640080" cy="713232"/>
           </a:xfrm>
           <a:prstGeom prst="rect">
@@ -5652,6 +5651,112 @@
             <a:r>
               <a:rPr lang="en-US" sz="2600" b="1" dirty="0">
                 <a:solidFill>
+                  <a:schemeClr val="accent3"/>
+                </a:solidFill>
+              </a:rPr>
+              <a:t>03</a:t>
+            </a:r>
+            <a:endParaRPr lang="en-US" sz="2600" dirty="0"/>
+          </a:p>
+        </p:txBody>
+      </p:sp>
+      <p:sp>
+        <p:nvSpPr>
+          <p:cNvPr id="15" name="Text 13"/>
+          <p:cNvSpPr txBox="1"/>
+          <p:nvPr/>
+        </p:nvSpPr>
+        <p:spPr>
+          <a:xfrm>
+            <a:off x="1371600" y="4983480"/>
+            <a:ext cx="1920240" cy="713232"/>
+          </a:xfrm>
+          <a:prstGeom prst="rect">
+            <a:avLst/>
+          </a:prstGeom>
+          <a:noFill/>
+          <a:ln/>
+        </p:spPr>
+        <p:txBody>
+          <a:bodyPr wrap="square" lIns="0" tIns="0" rIns="0" bIns="0" rtlCol="0" anchor="ctr"/>
+          <a:lstStyle/>
+          <a:p>
+            <a:pPr indent="0" marL="0">
+              <a:buNone/>
+            </a:pPr>
+            <a:r>
+              <a:rPr lang="en-US" sz="1700" b="1" dirty="0">
+                <a:solidFill>
+                  <a:schemeClr val="tx1"/>
+                </a:solidFill>
+              </a:rPr>
+              <a:t>NG Tube Feeding</a:t>
+            </a:r>
+            <a:endParaRPr lang="en-US" sz="1700" dirty="0"/>
+          </a:p>
+        </p:txBody>
+      </p:sp>
+      <p:sp>
+        <p:nvSpPr>
+          <p:cNvPr id="16" name="Part card"/>
+          <p:cNvSpPr/>
+          <p:nvPr/>
+        </p:nvSpPr>
+        <p:spPr>
+          <a:xfrm>
+            <a:off x="3520440" y="4983480"/>
+            <a:ext cx="2788920" cy="713232"/>
+          </a:xfrm>
+          <a:prstGeom prst="roundRect">
+            <a:avLst>
+              <a:gd name="adj" fmla="val 15385"/>
+            </a:avLst>
+          </a:prstGeom>
+          <a:solidFill>
+            <a:schemeClr val="bg1"/>
+          </a:solidFill>
+          <a:ln w="9525">
+            <a:solidFill>
+              <a:srgbClr val="CDDADC"/>
+            </a:solidFill>
+            <a:prstDash val="solid"/>
+          </a:ln>
+          <a:effectLst>
+            <a:outerShdw sx="100000" sy="100000" kx="0" ky="0" algn="bl" rotWithShape="0" blurRad="76200" dist="25400" dir="5400000">
+              <a:srgbClr val="11262D">
+                <a:alpha val="8000"/>
+              </a:srgbClr>
+            </a:outerShdw>
+          </a:effectLst>
+        </p:spPr>
+      </p:sp>
+      <p:sp>
+        <p:nvSpPr>
+          <p:cNvPr id="17" name="Text 15"/>
+          <p:cNvSpPr txBox="1"/>
+          <p:nvPr/>
+        </p:nvSpPr>
+        <p:spPr>
+          <a:xfrm>
+            <a:off x="3703320" y="4983480"/>
+            <a:ext cx="640080" cy="713232"/>
+          </a:xfrm>
+          <a:prstGeom prst="rect">
+            <a:avLst/>
+          </a:prstGeom>
+          <a:noFill/>
+          <a:ln/>
+        </p:spPr>
+        <p:txBody>
+          <a:bodyPr wrap="square" lIns="0" tIns="0" rIns="0" bIns="0" rtlCol="0" anchor="ctr"/>
+          <a:lstStyle/>
+          <a:p>
+            <a:pPr indent="0" marL="0">
+              <a:buNone/>
+            </a:pPr>
+            <a:r>
+              <a:rPr lang="en-US" sz="2600" b="1" dirty="0">
+                <a:solidFill>
                   <a:schemeClr val="accent4"/>
                 </a:solidFill>
               </a:rPr>
@@ -5663,13 +5768,13 @@
       </p:sp>
       <p:sp>
         <p:nvSpPr>
-          <p:cNvPr id="15" name="Text 13"/>
-          <p:cNvSpPr txBox="1"/>
-          <p:nvPr/>
-        </p:nvSpPr>
-        <p:spPr>
-          <a:xfrm>
-            <a:off x="4343400" y="4297680"/>
+          <p:cNvPr id="18" name="Text 16"/>
+          <p:cNvSpPr txBox="1"/>
+          <p:nvPr/>
+        </p:nvSpPr>
+        <p:spPr>
+          <a:xfrm>
+            <a:off x="4343400" y="4983480"/>
             <a:ext cx="1920240" cy="713232"/>
           </a:xfrm>
           <a:prstGeom prst="rect">
@@ -5699,7 +5804,7 @@
       </p:sp>
       <p:pic>
         <p:nvPicPr>
-          <p:cNvPr id="16" name="Illustration hero3d-t" descr="3D models: milk drop, feeding bottle, feeding tube and spoon">    </p:cNvPr>
+          <p:cNvPr id="19" name="Illustration hero3d-t" descr="3D models: milk drop, feeding bottle, feeding tube and spoon">    </p:cNvPr>
           <p:cNvPicPr>
             <a:picLocks noChangeAspect="1"/>
           </p:cNvPicPr>
@@ -22804,7 +22909,7 @@
                   <a:schemeClr val="tx1"/>
                 </a:solidFill>
               </a:rPr>
-              <a:t>NG feeding procedure</a:t>
+              <a:t>NG tube insertion procedure</a:t>
             </a:r>
             <a:endParaRPr lang="en-US" sz="3600" dirty="0"/>
           </a:p>
@@ -22818,7 +22923,7 @@
         </p:nvSpPr>
         <p:spPr>
           <a:xfrm>
-            <a:off x="548640" y="1490472"/>
+            <a:off x="548640" y="1481328"/>
             <a:ext cx="402336" cy="402336"/>
           </a:xfrm>
           <a:prstGeom prst="ellipse">
@@ -22843,7 +22948,7 @@
         </p:nvSpPr>
         <p:spPr>
           <a:xfrm>
-            <a:off x="548640" y="1490472"/>
+            <a:off x="548640" y="1481328"/>
             <a:ext cx="402336" cy="402336"/>
           </a:xfrm>
           <a:prstGeom prst="rect">
@@ -22879,8 +22984,8 @@
         </p:nvSpPr>
         <p:spPr>
           <a:xfrm>
-            <a:off x="1097280" y="1417320"/>
-            <a:ext cx="4937760" cy="548640"/>
+            <a:off x="1097280" y="1371600"/>
+            <a:ext cx="4983480" cy="640080"/>
           </a:xfrm>
           <a:prstGeom prst="rect">
             <a:avLst/>
@@ -22896,14 +23001,36 @@
               <a:buNone/>
             </a:pPr>
             <a:r>
-              <a:rPr lang="en-US" sz="1500" dirty="0">
+              <a:rPr lang="en-US" sz="1400" dirty="0">
                 <a:solidFill>
                   <a:schemeClr val="tx1"/>
                 </a:solidFill>
               </a:rPr>
-              <a:t>Perform hand hygiene.</a:t>
-            </a:r>
-            <a:endParaRPr lang="en-US" sz="1500" dirty="0"/>
+              <a:t>Wash hands and prepare the </a:t>
+            </a:r>
+            <a:pPr indent="0" marL="0">
+              <a:buNone/>
+            </a:pPr>
+            <a:r>
+              <a:rPr lang="en-US" sz="1400" b="1" dirty="0">
+                <a:solidFill>
+                  <a:schemeClr val="tx1"/>
+                </a:solidFill>
+              </a:rPr>
+              <a:t>NG tube, lubricant, syringe, pH paper and fixation tape</a:t>
+            </a:r>
+            <a:pPr indent="0" marL="0">
+              <a:buNone/>
+            </a:pPr>
+            <a:r>
+              <a:rPr lang="en-US" sz="1400" dirty="0">
+                <a:solidFill>
+                  <a:schemeClr val="tx1"/>
+                </a:solidFill>
+              </a:rPr>
+              <a:t>.</a:t>
+            </a:r>
+            <a:endParaRPr lang="en-US" sz="1400" dirty="0"/>
           </a:p>
         </p:txBody>
       </p:sp>
@@ -22915,7 +23042,7 @@
         </p:nvSpPr>
         <p:spPr>
           <a:xfrm>
-            <a:off x="548640" y="2130552"/>
+            <a:off x="548640" y="2176272"/>
             <a:ext cx="402336" cy="402336"/>
           </a:xfrm>
           <a:prstGeom prst="ellipse">
@@ -22940,7 +23067,7 @@
         </p:nvSpPr>
         <p:spPr>
           <a:xfrm>
-            <a:off x="548640" y="2130552"/>
+            <a:off x="548640" y="2176272"/>
             <a:ext cx="402336" cy="402336"/>
           </a:xfrm>
           <a:prstGeom prst="rect">
@@ -22976,8 +23103,8 @@
         </p:nvSpPr>
         <p:spPr>
           <a:xfrm>
-            <a:off x="1097280" y="2057400"/>
-            <a:ext cx="4937760" cy="548640"/>
+            <a:off x="1097280" y="2066544"/>
+            <a:ext cx="4983480" cy="640080"/>
           </a:xfrm>
           <a:prstGeom prst="rect">
             <a:avLst/>
@@ -22993,14 +23120,36 @@
               <a:buNone/>
             </a:pPr>
             <a:r>
-              <a:rPr lang="en-US" sz="1500" dirty="0">
+              <a:rPr lang="en-US" sz="1400" dirty="0">
                 <a:solidFill>
                   <a:schemeClr val="tx1"/>
                 </a:solidFill>
               </a:rPr>
-              <a:t>Position the infant safely, usually semi-upright.</a:t>
-            </a:r>
-            <a:endParaRPr lang="en-US" sz="1500" dirty="0"/>
+              <a:t>Explain the procedure to the child / parents and position the child </a:t>
+            </a:r>
+            <a:pPr indent="0" marL="0">
+              <a:buNone/>
+            </a:pPr>
+            <a:r>
+              <a:rPr lang="en-US" sz="1400" b="1" dirty="0">
+                <a:solidFill>
+                  <a:schemeClr val="tx1"/>
+                </a:solidFill>
+              </a:rPr>
+              <a:t>upright or semi-upright</a:t>
+            </a:r>
+            <a:pPr indent="0" marL="0">
+              <a:buNone/>
+            </a:pPr>
+            <a:r>
+              <a:rPr lang="en-US" sz="1400" dirty="0">
+                <a:solidFill>
+                  <a:schemeClr val="tx1"/>
+                </a:solidFill>
+              </a:rPr>
+              <a:t>.</a:t>
+            </a:r>
+            <a:endParaRPr lang="en-US" sz="1400" dirty="0"/>
           </a:p>
         </p:txBody>
       </p:sp>
@@ -23012,7 +23161,7 @@
         </p:nvSpPr>
         <p:spPr>
           <a:xfrm>
-            <a:off x="548640" y="2770632"/>
+            <a:off x="548640" y="2871216"/>
             <a:ext cx="402336" cy="402336"/>
           </a:xfrm>
           <a:prstGeom prst="ellipse">
@@ -23037,7 +23186,7 @@
         </p:nvSpPr>
         <p:spPr>
           <a:xfrm>
-            <a:off x="548640" y="2770632"/>
+            <a:off x="548640" y="2871216"/>
             <a:ext cx="402336" cy="402336"/>
           </a:xfrm>
           <a:prstGeom prst="rect">
@@ -23073,8 +23222,8 @@
         </p:nvSpPr>
         <p:spPr>
           <a:xfrm>
-            <a:off x="1097280" y="2697480"/>
-            <a:ext cx="4937760" cy="548640"/>
+            <a:off x="1097280" y="2761488"/>
+            <a:ext cx="4983480" cy="640080"/>
           </a:xfrm>
           <a:prstGeom prst="rect">
             <a:avLst/>
@@ -23090,14 +23239,36 @@
               <a:buNone/>
             </a:pPr>
             <a:r>
-              <a:rPr lang="en-US" sz="1500" dirty="0">
+              <a:rPr lang="en-US" sz="1400" dirty="0">
                 <a:solidFill>
                   <a:schemeClr val="tx1"/>
                 </a:solidFill>
               </a:rPr>
-              <a:t>Verify NG tube placement according to protocol.</a:t>
-            </a:r>
-            <a:endParaRPr lang="en-US" sz="1500" dirty="0"/>
+              <a:t>Measure the tube from the </a:t>
+            </a:r>
+            <a:pPr indent="0" marL="0">
+              <a:buNone/>
+            </a:pPr>
+            <a:r>
+              <a:rPr lang="en-US" sz="1400" b="1" dirty="0">
+                <a:solidFill>
+                  <a:schemeClr val="tx1"/>
+                </a:solidFill>
+              </a:rPr>
+              <a:t>nose → earlobe → midpoint between xiphoid and umbilicus</a:t>
+            </a:r>
+            <a:pPr indent="0" marL="0">
+              <a:buNone/>
+            </a:pPr>
+            <a:r>
+              <a:rPr lang="en-US" sz="1400" dirty="0">
+                <a:solidFill>
+                  <a:schemeClr val="tx1"/>
+                </a:solidFill>
+              </a:rPr>
+              <a:t>.</a:t>
+            </a:r>
+            <a:endParaRPr lang="en-US" sz="1400" dirty="0"/>
           </a:p>
         </p:txBody>
       </p:sp>
@@ -23109,7 +23280,7 @@
         </p:nvSpPr>
         <p:spPr>
           <a:xfrm>
-            <a:off x="548640" y="3410712"/>
+            <a:off x="548640" y="3566160"/>
             <a:ext cx="402336" cy="402336"/>
           </a:xfrm>
           <a:prstGeom prst="ellipse">
@@ -23134,7 +23305,7 @@
         </p:nvSpPr>
         <p:spPr>
           <a:xfrm>
-            <a:off x="548640" y="3410712"/>
+            <a:off x="548640" y="3566160"/>
             <a:ext cx="402336" cy="402336"/>
           </a:xfrm>
           <a:prstGeom prst="rect">
@@ -23170,8 +23341,8 @@
         </p:nvSpPr>
         <p:spPr>
           <a:xfrm>
-            <a:off x="1097280" y="3337560"/>
-            <a:ext cx="4937760" cy="548640"/>
+            <a:off x="1097280" y="3456432"/>
+            <a:ext cx="4983480" cy="640080"/>
           </a:xfrm>
           <a:prstGeom prst="rect">
             <a:avLst/>
@@ -23187,14 +23358,25 @@
               <a:buNone/>
             </a:pPr>
             <a:r>
-              <a:rPr lang="en-US" sz="1500" dirty="0">
+              <a:rPr lang="en-US" sz="1400" b="1" dirty="0">
                 <a:solidFill>
                   <a:schemeClr val="tx1"/>
                 </a:solidFill>
               </a:rPr>
-              <a:t>Check the prescribed feed.</a:t>
-            </a:r>
-            <a:endParaRPr lang="en-US" sz="1500" dirty="0"/>
+              <a:t>Mark</a:t>
+            </a:r>
+            <a:pPr indent="0" marL="0">
+              <a:buNone/>
+            </a:pPr>
+            <a:r>
+              <a:rPr lang="en-US" sz="1400" dirty="0">
+                <a:solidFill>
+                  <a:schemeClr val="tx1"/>
+                </a:solidFill>
+              </a:rPr>
+              <a:t> the measured length on the tube.</a:t>
+            </a:r>
+            <a:endParaRPr lang="en-US" sz="1400" dirty="0"/>
           </a:p>
         </p:txBody>
       </p:sp>
@@ -23206,7 +23388,7 @@
         </p:nvSpPr>
         <p:spPr>
           <a:xfrm>
-            <a:off x="548640" y="4050792"/>
+            <a:off x="548640" y="4261104"/>
             <a:ext cx="402336" cy="402336"/>
           </a:xfrm>
           <a:prstGeom prst="ellipse">
@@ -23231,7 +23413,7 @@
         </p:nvSpPr>
         <p:spPr>
           <a:xfrm>
-            <a:off x="548640" y="4050792"/>
+            <a:off x="548640" y="4261104"/>
             <a:ext cx="402336" cy="402336"/>
           </a:xfrm>
           <a:prstGeom prst="rect">
@@ -23267,8 +23449,8 @@
         </p:nvSpPr>
         <p:spPr>
           <a:xfrm>
-            <a:off x="1097280" y="3977640"/>
-            <a:ext cx="4937760" cy="548640"/>
+            <a:off x="1097280" y="4151376"/>
+            <a:ext cx="4983480" cy="640080"/>
           </a:xfrm>
           <a:prstGeom prst="rect">
             <a:avLst/>
@@ -23284,14 +23466,36 @@
               <a:buNone/>
             </a:pPr>
             <a:r>
-              <a:rPr lang="en-US" sz="1500" dirty="0">
+              <a:rPr lang="en-US" sz="1400" dirty="0">
                 <a:solidFill>
                   <a:schemeClr val="tx1"/>
                 </a:solidFill>
               </a:rPr>
-              <a:t>Administer the feed at the prescribed rate.</a:t>
-            </a:r>
-            <a:endParaRPr lang="en-US" sz="1500" dirty="0"/>
+              <a:t>Lubricate the tip of the NG tube with a </a:t>
+            </a:r>
+            <a:pPr indent="0" marL="0">
+              <a:buNone/>
+            </a:pPr>
+            <a:r>
+              <a:rPr lang="en-US" sz="1400" b="1" dirty="0">
+                <a:solidFill>
+                  <a:schemeClr val="tx1"/>
+                </a:solidFill>
+              </a:rPr>
+              <a:t>water-soluble lubricant</a:t>
+            </a:r>
+            <a:pPr indent="0" marL="0">
+              <a:buNone/>
+            </a:pPr>
+            <a:r>
+              <a:rPr lang="en-US" sz="1400" dirty="0">
+                <a:solidFill>
+                  <a:schemeClr val="tx1"/>
+                </a:solidFill>
+              </a:rPr>
+              <a:t>.</a:t>
+            </a:r>
+            <a:endParaRPr lang="en-US" sz="1400" dirty="0"/>
           </a:p>
         </p:txBody>
       </p:sp>
@@ -23303,7 +23507,7 @@
         </p:nvSpPr>
         <p:spPr>
           <a:xfrm>
-            <a:off x="6217920" y="1490472"/>
+            <a:off x="6217920" y="1481328"/>
             <a:ext cx="402336" cy="402336"/>
           </a:xfrm>
           <a:prstGeom prst="ellipse">
@@ -23328,7 +23532,7 @@
         </p:nvSpPr>
         <p:spPr>
           <a:xfrm>
-            <a:off x="6217920" y="1490472"/>
+            <a:off x="6217920" y="1481328"/>
             <a:ext cx="402336" cy="402336"/>
           </a:xfrm>
           <a:prstGeom prst="rect">
@@ -23364,8 +23568,8 @@
         </p:nvSpPr>
         <p:spPr>
           <a:xfrm>
-            <a:off x="6766560" y="1417320"/>
-            <a:ext cx="4937760" cy="548640"/>
+            <a:off x="6766560" y="1371600"/>
+            <a:ext cx="4983480" cy="640080"/>
           </a:xfrm>
           <a:prstGeom prst="rect">
             <a:avLst/>
@@ -23381,14 +23585,36 @@
               <a:buNone/>
             </a:pPr>
             <a:r>
-              <a:rPr lang="en-US" sz="1500" dirty="0">
+              <a:rPr lang="en-US" sz="1400" dirty="0">
                 <a:solidFill>
                   <a:schemeClr val="tx1"/>
                 </a:solidFill>
               </a:rPr>
-              <a:t>Observe the infant throughout feeding.</a:t>
-            </a:r>
-            <a:endParaRPr lang="en-US" sz="1500" dirty="0"/>
+              <a:t>Insert the tube gently through the nostril, directing it </a:t>
+            </a:r>
+            <a:pPr indent="0" marL="0">
+              <a:buNone/>
+            </a:pPr>
+            <a:r>
+              <a:rPr lang="en-US" sz="1400" b="1" dirty="0">
+                <a:solidFill>
+                  <a:schemeClr val="tx1"/>
+                </a:solidFill>
+              </a:rPr>
+              <a:t>backward, not upward</a:t>
+            </a:r>
+            <a:pPr indent="0" marL="0">
+              <a:buNone/>
+            </a:pPr>
+            <a:r>
+              <a:rPr lang="en-US" sz="1400" dirty="0">
+                <a:solidFill>
+                  <a:schemeClr val="tx1"/>
+                </a:solidFill>
+              </a:rPr>
+              <a:t>.</a:t>
+            </a:r>
+            <a:endParaRPr lang="en-US" sz="1400" dirty="0"/>
           </a:p>
         </p:txBody>
       </p:sp>
@@ -23400,7 +23626,7 @@
         </p:nvSpPr>
         <p:spPr>
           <a:xfrm>
-            <a:off x="6217920" y="2130552"/>
+            <a:off x="6217920" y="2176272"/>
             <a:ext cx="402336" cy="402336"/>
           </a:xfrm>
           <a:prstGeom prst="ellipse">
@@ -23425,7 +23651,7 @@
         </p:nvSpPr>
         <p:spPr>
           <a:xfrm>
-            <a:off x="6217920" y="2130552"/>
+            <a:off x="6217920" y="2176272"/>
             <a:ext cx="402336" cy="402336"/>
           </a:xfrm>
           <a:prstGeom prst="rect">
@@ -23461,8 +23687,8 @@
         </p:nvSpPr>
         <p:spPr>
           <a:xfrm>
-            <a:off x="6766560" y="2057400"/>
-            <a:ext cx="4937760" cy="548640"/>
+            <a:off x="6766560" y="2066544"/>
+            <a:ext cx="4983480" cy="640080"/>
           </a:xfrm>
           <a:prstGeom prst="rect">
             <a:avLst/>
@@ -23478,14 +23704,36 @@
               <a:buNone/>
             </a:pPr>
             <a:r>
-              <a:rPr lang="en-US" sz="1500" dirty="0">
+              <a:rPr lang="en-US" sz="1400" dirty="0">
                 <a:solidFill>
                   <a:schemeClr val="tx1"/>
                 </a:solidFill>
               </a:rPr>
-              <a:t>Stop feeding if concerning signs occur (see below).</a:t>
-            </a:r>
-            <a:endParaRPr lang="en-US" sz="1500" dirty="0"/>
+              <a:t>Encourage swallowing in older children; use a </a:t>
+            </a:r>
+            <a:pPr indent="0" marL="0">
+              <a:buNone/>
+            </a:pPr>
+            <a:r>
+              <a:rPr lang="en-US" sz="1400" b="1" dirty="0">
+                <a:solidFill>
+                  <a:schemeClr val="tx1"/>
+                </a:solidFill>
+              </a:rPr>
+              <a:t>pacifier</a:t>
+            </a:r>
+            <a:pPr indent="0" marL="0">
+              <a:buNone/>
+            </a:pPr>
+            <a:r>
+              <a:rPr lang="en-US" sz="1400" dirty="0">
+                <a:solidFill>
+                  <a:schemeClr val="tx1"/>
+                </a:solidFill>
+              </a:rPr>
+              <a:t> to help infants swallow.</a:t>
+            </a:r>
+            <a:endParaRPr lang="en-US" sz="1400" dirty="0"/>
           </a:p>
         </p:txBody>
       </p:sp>
@@ -23497,7 +23745,7 @@
         </p:nvSpPr>
         <p:spPr>
           <a:xfrm>
-            <a:off x="6217920" y="2770632"/>
+            <a:off x="6217920" y="2871216"/>
             <a:ext cx="402336" cy="402336"/>
           </a:xfrm>
           <a:prstGeom prst="ellipse">
@@ -23522,7 +23770,7 @@
         </p:nvSpPr>
         <p:spPr>
           <a:xfrm>
-            <a:off x="6217920" y="2770632"/>
+            <a:off x="6217920" y="2871216"/>
             <a:ext cx="402336" cy="402336"/>
           </a:xfrm>
           <a:prstGeom prst="rect">
@@ -23558,8 +23806,8 @@
         </p:nvSpPr>
         <p:spPr>
           <a:xfrm>
-            <a:off x="6766560" y="2697480"/>
-            <a:ext cx="4937760" cy="548640"/>
+            <a:off x="6766560" y="2761488"/>
+            <a:ext cx="4983480" cy="640080"/>
           </a:xfrm>
           <a:prstGeom prst="rect">
             <a:avLst/>
@@ -23575,14 +23823,36 @@
               <a:buNone/>
             </a:pPr>
             <a:r>
-              <a:rPr lang="en-US" sz="1500" dirty="0">
+              <a:rPr lang="en-US" sz="1400" dirty="0">
                 <a:solidFill>
                   <a:schemeClr val="tx1"/>
                 </a:solidFill>
               </a:rPr>
-              <a:t>Flush the tube only according to the prescribed / appropriate protocol.</a:t>
-            </a:r>
-            <a:endParaRPr lang="en-US" sz="1500" dirty="0"/>
+              <a:t>If distress occurs, </a:t>
+            </a:r>
+            <a:pPr indent="0" marL="0">
+              <a:buNone/>
+            </a:pPr>
+            <a:r>
+              <a:rPr lang="en-US" sz="1400" b="1" dirty="0">
+                <a:solidFill>
+                  <a:schemeClr val="tx1"/>
+                </a:solidFill>
+              </a:rPr>
+              <a:t>stop and remove the tube</a:t>
+            </a:r>
+            <a:pPr indent="0" marL="0">
+              <a:buNone/>
+            </a:pPr>
+            <a:r>
+              <a:rPr lang="en-US" sz="1400" dirty="0">
+                <a:solidFill>
+                  <a:schemeClr val="tx1"/>
+                </a:solidFill>
+              </a:rPr>
+              <a:t> (see below).</a:t>
+            </a:r>
+            <a:endParaRPr lang="en-US" sz="1400" dirty="0"/>
           </a:p>
         </p:txBody>
       </p:sp>
@@ -23594,7 +23864,7 @@
         </p:nvSpPr>
         <p:spPr>
           <a:xfrm>
-            <a:off x="6217920" y="3410712"/>
+            <a:off x="6217920" y="3566160"/>
             <a:ext cx="402336" cy="402336"/>
           </a:xfrm>
           <a:prstGeom prst="ellipse">
@@ -23619,7 +23889,7 @@
         </p:nvSpPr>
         <p:spPr>
           <a:xfrm>
-            <a:off x="6217920" y="3410712"/>
+            <a:off x="6217920" y="3566160"/>
             <a:ext cx="402336" cy="402336"/>
           </a:xfrm>
           <a:prstGeom prst="rect">
@@ -23655,8 +23925,8 @@
         </p:nvSpPr>
         <p:spPr>
           <a:xfrm>
-            <a:off x="6766560" y="3337560"/>
-            <a:ext cx="4937760" cy="548640"/>
+            <a:off x="6766560" y="3456432"/>
+            <a:ext cx="4983480" cy="640080"/>
           </a:xfrm>
           <a:prstGeom prst="rect">
             <a:avLst/>
@@ -23672,14 +23942,58 @@
               <a:buNone/>
             </a:pPr>
             <a:r>
-              <a:rPr lang="en-US" sz="1500" dirty="0">
+              <a:rPr lang="en-US" sz="1400" dirty="0">
                 <a:solidFill>
                   <a:schemeClr val="tx1"/>
                 </a:solidFill>
               </a:rPr>
-              <a:t>Keep the infant appropriately positioned after feeding.</a:t>
-            </a:r>
-            <a:endParaRPr lang="en-US" sz="1500" dirty="0"/>
+              <a:t>Confirm position using </a:t>
+            </a:r>
+            <a:pPr indent="0" marL="0">
+              <a:buNone/>
+            </a:pPr>
+            <a:r>
+              <a:rPr lang="en-US" sz="1400" b="1" dirty="0">
+                <a:solidFill>
+                  <a:schemeClr val="tx1"/>
+                </a:solidFill>
+              </a:rPr>
+              <a:t>gastric aspirate and pH testing</a:t>
+            </a:r>
+            <a:pPr indent="0" marL="0">
+              <a:buNone/>
+            </a:pPr>
+            <a:r>
+              <a:rPr lang="en-US" sz="1400" dirty="0">
+                <a:solidFill>
+                  <a:schemeClr val="tx1"/>
+                </a:solidFill>
+              </a:rPr>
+              <a:t> according to local protocol; </a:t>
+            </a:r>
+            <a:pPr indent="0" marL="0">
+              <a:buNone/>
+            </a:pPr>
+            <a:r>
+              <a:rPr lang="en-US" sz="1400" b="1" dirty="0">
+                <a:solidFill>
+                  <a:schemeClr val="tx1"/>
+                </a:solidFill>
+              </a:rPr>
+              <a:t>X-ray</a:t>
+            </a:r>
+            <a:pPr indent="0" marL="0">
+              <a:buNone/>
+            </a:pPr>
+            <a:r>
+              <a:rPr lang="en-US" sz="1400" dirty="0">
+                <a:solidFill>
+                  <a:schemeClr val="tx1"/>
+                </a:solidFill>
+              </a:rPr>
+              <a:t> may be required if placement is uncertain.</a:t>
+            </a:r>
+            <a:endParaRPr lang="en-US" sz="1400" dirty="0"/>
           </a:p>
         </p:txBody>
       </p:sp>
@@ -23691,7 +24005,7 @@
         </p:nvSpPr>
         <p:spPr>
           <a:xfrm>
-            <a:off x="6217920" y="4050792"/>
+            <a:off x="6217920" y="4261104"/>
             <a:ext cx="402336" cy="402336"/>
           </a:xfrm>
           <a:prstGeom prst="ellipse">
@@ -23716,7 +24030,7 @@
         </p:nvSpPr>
         <p:spPr>
           <a:xfrm>
-            <a:off x="6217920" y="4050792"/>
+            <a:off x="6217920" y="4261104"/>
             <a:ext cx="402336" cy="402336"/>
           </a:xfrm>
           <a:prstGeom prst="rect">
@@ -23752,8 +24066,8 @@
         </p:nvSpPr>
         <p:spPr>
           <a:xfrm>
-            <a:off x="6766560" y="3977640"/>
-            <a:ext cx="4937760" cy="548640"/>
+            <a:off x="6766560" y="4151376"/>
+            <a:ext cx="4983480" cy="640080"/>
           </a:xfrm>
           <a:prstGeom prst="rect">
             <a:avLst/>
@@ -23769,14 +24083,47 @@
               <a:buNone/>
             </a:pPr>
             <a:r>
-              <a:rPr lang="en-US" sz="1500" dirty="0">
+              <a:rPr lang="en-US" sz="1400" b="1" dirty="0">
                 <a:solidFill>
                   <a:schemeClr val="tx1"/>
                 </a:solidFill>
               </a:rPr>
-              <a:t>Document the feeding and the infant’s response.</a:t>
-            </a:r>
-            <a:endParaRPr lang="en-US" sz="1500" dirty="0"/>
+              <a:t>Secure</a:t>
+            </a:r>
+            <a:pPr indent="0" marL="0">
+              <a:buNone/>
+            </a:pPr>
+            <a:r>
+              <a:rPr lang="en-US" sz="1400" dirty="0">
+                <a:solidFill>
+                  <a:schemeClr val="tx1"/>
+                </a:solidFill>
+              </a:rPr>
+              <a:t> the tube to the nose / cheek, </a:t>
+            </a:r>
+            <a:pPr indent="0" marL="0">
+              <a:buNone/>
+            </a:pPr>
+            <a:r>
+              <a:rPr lang="en-US" sz="1400" b="1" dirty="0">
+                <a:solidFill>
+                  <a:schemeClr val="tx1"/>
+                </a:solidFill>
+              </a:rPr>
+              <a:t>record the external tube length</a:t>
+            </a:r>
+            <a:pPr indent="0" marL="0">
+              <a:buNone/>
+            </a:pPr>
+            <a:r>
+              <a:rPr lang="en-US" sz="1400" dirty="0">
+                <a:solidFill>
+                  <a:schemeClr val="tx1"/>
+                </a:solidFill>
+              </a:rPr>
+              <a:t>, and give no feeding or medication until correct placement is confirmed.</a:t>
+            </a:r>
+            <a:endParaRPr lang="en-US" sz="1400" dirty="0"/>
           </a:p>
         </p:txBody>
       </p:sp>
@@ -23788,12 +24135,12 @@
         </p:nvSpPr>
         <p:spPr>
           <a:xfrm>
-            <a:off x="548640" y="4754880"/>
-            <a:ext cx="11109960" cy="1508760"/>
+            <a:off x="548640" y="4956048"/>
+            <a:ext cx="11109960" cy="1353312"/>
           </a:xfrm>
           <a:prstGeom prst="roundRect">
             <a:avLst>
-              <a:gd name="adj" fmla="val 7273"/>
+              <a:gd name="adj" fmla="val 8108"/>
             </a:avLst>
           </a:prstGeom>
           <a:solidFill>
@@ -23824,8 +24171,8 @@
         </p:nvSpPr>
         <p:spPr>
           <a:xfrm>
-            <a:off x="777240" y="4983480"/>
-            <a:ext cx="1051560" cy="1051560"/>
+            <a:off x="777240" y="5120640"/>
+            <a:ext cx="1005840" cy="1005840"/>
           </a:xfrm>
           <a:prstGeom prst="octagon">
             <a:avLst/>
@@ -23844,8 +24191,8 @@
         </p:nvSpPr>
         <p:spPr>
           <a:xfrm>
-            <a:off x="777240" y="4983480"/>
-            <a:ext cx="1051560" cy="1051560"/>
+            <a:off x="777240" y="5120640"/>
+            <a:ext cx="1005840" cy="1005840"/>
           </a:xfrm>
           <a:prstGeom prst="rect">
             <a:avLst/>
@@ -23880,8 +24227,8 @@
         </p:nvSpPr>
         <p:spPr>
           <a:xfrm>
-            <a:off x="2057400" y="4846320"/>
-            <a:ext cx="9418320" cy="548640"/>
+            <a:off x="2011680" y="5029200"/>
+            <a:ext cx="9509760" cy="502920"/>
           </a:xfrm>
           <a:prstGeom prst="rect">
             <a:avLst/>
@@ -23902,7 +24249,7 @@
                   <a:schemeClr val="tx1"/>
                 </a:solidFill>
               </a:rPr>
-              <a:t>Stop feeding if significant respiratory distress, vomiting, coughing, cyanosis or other concerning signs occur.</a:t>
+              <a:t>If severe coughing, choking, cyanosis or respiratory distress occurs, stop and remove the tube.</a:t>
             </a:r>
             <a:endParaRPr lang="en-US" sz="1600" dirty="0"/>
           </a:p>
@@ -23910,7 +24257,7 @@
       </p:sp>
       <p:pic>
         <p:nvPicPr>
-          <p:cNvPr id="38" name="Image 0" descr="Respiratory distress">    </p:cNvPr>
+          <p:cNvPr id="38" name="Image 0" descr="Severe coughing">    </p:cNvPr>
           <p:cNvPicPr>
             <a:picLocks noChangeAspect="1"/>
           </p:cNvPicPr>
@@ -23924,8 +24271,8 @@
         </p:blipFill>
         <p:spPr>
           <a:xfrm>
-            <a:off x="2057400" y="5486400"/>
-            <a:ext cx="548640" cy="548640"/>
+            <a:off x="2011680" y="5596128"/>
+            <a:ext cx="502920" cy="502920"/>
           </a:xfrm>
           <a:prstGeom prst="rect">
             <a:avLst/>
@@ -23940,8 +24287,8 @@
         </p:nvSpPr>
         <p:spPr>
           <a:xfrm>
-            <a:off x="2697480" y="5486400"/>
-            <a:ext cx="1691640" cy="548640"/>
+            <a:off x="2606040" y="5596128"/>
+            <a:ext cx="1737360" cy="502920"/>
           </a:xfrm>
           <a:prstGeom prst="rect">
             <a:avLst/>
@@ -23962,7 +24309,7 @@
                   <a:schemeClr val="tx1"/>
                 </a:solidFill>
               </a:rPr>
-              <a:t>Respiratory distress</a:t>
+              <a:t>Severe coughing</a:t>
             </a:r>
             <a:endParaRPr lang="en-US" sz="1400" dirty="0"/>
           </a:p>
@@ -23970,7 +24317,7 @@
       </p:sp>
       <p:pic>
         <p:nvPicPr>
-          <p:cNvPr id="40" name="Image 1" descr="Vomiting">    </p:cNvPr>
+          <p:cNvPr id="40" name="Image 1" descr="Choking">    </p:cNvPr>
           <p:cNvPicPr>
             <a:picLocks noChangeAspect="1"/>
           </p:cNvPicPr>
@@ -23984,8 +24331,8 @@
         </p:blipFill>
         <p:spPr>
           <a:xfrm>
-            <a:off x="4434840" y="5486400"/>
-            <a:ext cx="548640" cy="548640"/>
+            <a:off x="4389120" y="5596128"/>
+            <a:ext cx="502920" cy="502920"/>
           </a:xfrm>
           <a:prstGeom prst="rect">
             <a:avLst/>
@@ -24000,8 +24347,8 @@
         </p:nvSpPr>
         <p:spPr>
           <a:xfrm>
-            <a:off x="5074920" y="5486400"/>
-            <a:ext cx="1691640" cy="548640"/>
+            <a:off x="4983480" y="5596128"/>
+            <a:ext cx="1737360" cy="502920"/>
           </a:xfrm>
           <a:prstGeom prst="rect">
             <a:avLst/>
@@ -24022,7 +24369,7 @@
                   <a:schemeClr val="tx1"/>
                 </a:solidFill>
               </a:rPr>
-              <a:t>Vomiting</a:t>
+              <a:t>Choking</a:t>
             </a:r>
             <a:endParaRPr lang="en-US" sz="1400" dirty="0"/>
           </a:p>
@@ -24030,7 +24377,7 @@
       </p:sp>
       <p:pic>
         <p:nvPicPr>
-          <p:cNvPr id="42" name="Image 2" descr="Coughing">    </p:cNvPr>
+          <p:cNvPr id="42" name="Image 2" descr="Cyanosis">    </p:cNvPr>
           <p:cNvPicPr>
             <a:picLocks noChangeAspect="1"/>
           </p:cNvPicPr>
@@ -24044,8 +24391,8 @@
         </p:blipFill>
         <p:spPr>
           <a:xfrm>
-            <a:off x="6812280" y="5486400"/>
-            <a:ext cx="548640" cy="548640"/>
+            <a:off x="6766560" y="5596128"/>
+            <a:ext cx="502920" cy="502920"/>
           </a:xfrm>
           <a:prstGeom prst="rect">
             <a:avLst/>
@@ -24060,8 +24407,8 @@
         </p:nvSpPr>
         <p:spPr>
           <a:xfrm>
-            <a:off x="7452360" y="5486400"/>
-            <a:ext cx="1691640" cy="548640"/>
+            <a:off x="7360920" y="5596128"/>
+            <a:ext cx="1737360" cy="502920"/>
           </a:xfrm>
           <a:prstGeom prst="rect">
             <a:avLst/>
@@ -24082,7 +24429,7 @@
                   <a:schemeClr val="tx1"/>
                 </a:solidFill>
               </a:rPr>
-              <a:t>Coughing</a:t>
+              <a:t>Cyanosis</a:t>
             </a:r>
             <a:endParaRPr lang="en-US" sz="1400" dirty="0"/>
           </a:p>
@@ -24090,7 +24437,7 @@
       </p:sp>
       <p:pic>
         <p:nvPicPr>
-          <p:cNvPr id="44" name="Image 3" descr="Cyanosis">    </p:cNvPr>
+          <p:cNvPr id="44" name="Image 3" descr="Respiratory distress">    </p:cNvPr>
           <p:cNvPicPr>
             <a:picLocks noChangeAspect="1"/>
           </p:cNvPicPr>
@@ -24104,8 +24451,8 @@
         </p:blipFill>
         <p:spPr>
           <a:xfrm>
-            <a:off x="9189720" y="5486400"/>
-            <a:ext cx="548640" cy="548640"/>
+            <a:off x="9144000" y="5596128"/>
+            <a:ext cx="502920" cy="502920"/>
           </a:xfrm>
           <a:prstGeom prst="rect">
             <a:avLst/>
@@ -24120,8 +24467,8 @@
         </p:nvSpPr>
         <p:spPr>
           <a:xfrm>
-            <a:off x="9829800" y="5486400"/>
-            <a:ext cx="1691640" cy="548640"/>
+            <a:off x="9738360" y="5596128"/>
+            <a:ext cx="1737360" cy="502920"/>
           </a:xfrm>
           <a:prstGeom prst="rect">
             <a:avLst/>
@@ -24142,7 +24489,7 @@
                   <a:schemeClr val="tx1"/>
                 </a:solidFill>
               </a:rPr>
-              <a:t>Cyanosis</a:t>
+              <a:t>Respiratory distress</a:t>
             </a:r>
             <a:endParaRPr lang="en-US" sz="1400" dirty="0"/>
           </a:p>

</xml_diff>